<commit_message>
updated the presentation and it's script .
</commit_message>
<xml_diff>
--- a/Presentation_and_report/CPU_LLM_Inference_Defense.pptx
+++ b/Presentation_and_report/CPU_LLM_Inference_Defense.pptx
@@ -2359,27 +2359,9 @@
             <a:noAutofit/>
           </a:bodyPr>
           <a:p>
-            <a:pPr marL="216000" indent="0">
-              <a:lnSpc>
-                <a:spcPct val="100000"/>
-              </a:lnSpc>
-              <a:buNone/>
-            </a:pPr>
             <a:r>
-              <a:rPr b="0" lang="en-US" sz="2000" spc="-1" strike="noStrike">
-                <a:solidFill>
-                  <a:srgbClr val="000000"/>
-                </a:solidFill>
-                <a:latin typeface="Arial"/>
-              </a:rPr>
-              <a:t>Good afternoon. My thesis asks a simple, practical question: if you don't have a GPU — and most computers in the world don't — what settings actually get you the most tokens per second out of a large language model, and what does it cost you in quality? I studied this empirically using llama.cpp across four very different CPUs. Let's walk through what I found.</a:t>
+              <a:t>Good afternoon. My thesis asks a simple, practical question: if you don't have a GPU — and most computers in the world don't — what settings actually get you the most tokens per second out of a large language model, and what does it cost you in quality? I studied this empirically using llama.cpp across three very different CPUs. Let's walk through what I found.</a:t>
             </a:r>
-            <a:endParaRPr b="0" lang="en-GB" sz="2000" spc="-1" strike="noStrike">
-              <a:solidFill>
-                <a:srgbClr val="000000"/>
-              </a:solidFill>
-              <a:latin typeface="Arial"/>
-            </a:endParaRPr>
           </a:p>
         </p:txBody>
       </p:sp>
@@ -3019,27 +3001,9 @@
             <a:noAutofit/>
           </a:bodyPr>
           <a:p>
-            <a:pPr marL="216000" indent="0">
-              <a:lnSpc>
-                <a:spcPct val="100000"/>
-              </a:lnSpc>
-              <a:buNone/>
-            </a:pPr>
             <a:r>
-              <a:rPr b="0" lang="en-US" sz="2000" spc="-1" strike="noStrike">
-                <a:solidFill>
-                  <a:srgbClr val="000000"/>
-                </a:solidFill>
-                <a:latin typeface="Arial"/>
-              </a:rPr>
-              <a:t>So, concretely, what should you do running llama.cpp on CPU? Six recommendations. One: turn Flash Attention off at long context — many front-ends enable it by default. Two: don't quantize the KV cache on compute-rich CPUs — use full-precision f16 unless you're on genuinely bandwidth-starved hardware. Three: set thread count to the physical core count, not the logical count — hyperthreads buy nothing for prefill and hurt generation. Four: on bandwidth-starved chips like the Pentium, single-threaded generation may be optimal — check before assuming more threads help. Five: on legacy CPUs without AVX-512, prefer simpler formats like Q4_0 for speed, K-quants only if quality matters more. Six — and I'll flag this as provisional — prefer MoE models on bandwidth-starved hardware, since the roofline model predicts they'll be disproportionately advantaged there. That last one is a hypothesis to test on your own hardware, not a settled recommendation.</a:t>
+              <a:t>So, concretely, what should you do running llama.cpp on CPU? Seven recommendations. One: turn Flash Attention off at long context — many front-ends enable it by default. Two: don't quantize the KV cache on compute-rich CPUs — use full-precision f16 unless you're on genuinely bandwidth-starved hardware. Three: set thread count to the physical core count, not the logical count — hyperthreads buy nothing for prefill and hurt generation. Four: on bandwidth-starved chips like the Pentium, single-threaded generation may be optimal — check before assuming more threads help. Five: on legacy CPUs without AVX-512, prefer simpler formats like Q4_0 for speed, K-quants only if quality matters more. Six — and I'll flag this as provisional — prefer MoE models on bandwidth-starved hardware, since the roofline model predicts they'll be disproportionately advantaged there; that one is a hypothesis to test on your own hardware, not a settled recommendation. And seven: match model size to the device's memory budget — a model that doesn't fit in RAM alongside its KV cache will thrash or fail outright, exactly what happened with the excluded Raspberry Pi 3B.</a:t>
             </a:r>
-            <a:endParaRPr b="0" lang="en-GB" sz="2000" spc="-1" strike="noStrike">
-              <a:solidFill>
-                <a:srgbClr val="000000"/>
-              </a:solidFill>
-              <a:latin typeface="Arial"/>
-            </a:endParaRPr>
           </a:p>
         </p:txBody>
       </p:sp>
@@ -3349,27 +3313,9 @@
             <a:noAutofit/>
           </a:bodyPr>
           <a:p>
-            <a:pPr marL="216000" indent="0">
-              <a:lnSpc>
-                <a:spcPct val="100000"/>
-              </a:lnSpc>
-              <a:buNone/>
-            </a:pPr>
             <a:r>
-              <a:rPr b="0" lang="en-US" sz="2000" spc="-1" strike="noStrike">
-                <a:solidFill>
-                  <a:srgbClr val="000000"/>
-                </a:solidFill>
-                <a:latin typeface="Arial"/>
-              </a:rPr>
-              <a:t>Near-term, five things: expand the hardware fleet — I especially want a working Raspberry Pi, an AVX-512 chip, and an Apple Silicon Mac. Actually run the MoE benchmarks to completion. Replace literature-based perplexity numbers with my own local measurements. Investigate CPU pinning and NUMA effects. And test Flash Attention and KV-cache quantization specifically on the bandwidth-starved machines, to check whether the predicted sign-flip actually happens there. Longer-term, the most ambitious direction is turning per-device calibration into a true zero-shot predictor — one that takes a CPU's raw specs and outputs its constants without ever touching the hardware — which would need on the order of twenty to thirty calibrated devices, ideally contributed by a community rather than one person's personal fleet.</a:t>
+              <a:t>Near-term, five things: expand the hardware fleet — I especially want a Raspberry Pi 4 or 5, an AVX-512 chip, and an Apple Silicon Mac. Actually run the MoE benchmarks to completion. Replace literature-based perplexity numbers with my own local measurements. Investigate CPU pinning and NUMA effects. And test Flash Attention and KV-cache quantization specifically on the bandwidth-starved machines, to check whether the predicted sign-flip actually happens there. Longer-term, the most ambitious direction is turning per-device calibration into a true zero-shot predictor — one that takes a CPU's raw specs and outputs its constants without ever touching the hardware — which would need on the order of twenty to thirty calibrated devices, ideally contributed by a community rather than one person's personal fleet.</a:t>
             </a:r>
-            <a:endParaRPr b="0" lang="en-GB" sz="2000" spc="-1" strike="noStrike">
-              <a:solidFill>
-                <a:srgbClr val="000000"/>
-              </a:solidFill>
-              <a:latin typeface="Arial"/>
-            </a:endParaRPr>
           </a:p>
         </p:txBody>
       </p:sp>
@@ -3514,27 +3460,9 @@
             <a:noAutofit/>
           </a:bodyPr>
           <a:p>
-            <a:pPr marL="216000" indent="0">
-              <a:lnSpc>
-                <a:spcPct val="100000"/>
-              </a:lnSpc>
-              <a:buNone/>
-            </a:pPr>
             <a:r>
-              <a:rPr b="0" lang="en-US" sz="2000" spc="-1" strike="noStrike">
-                <a:solidFill>
-                  <a:srgbClr val="000000"/>
-                </a:solidFill>
-                <a:latin typeface="Arial"/>
-              </a:rPr>
-              <a:t>To close: four consumer and embedded CPUs, three of which gave me usable data, were enough to recover four concrete, reproducible effects governing CPU-only LLM inference — compute-bound prefill that follows a scalability law, memory-bound generation that can get slower as you add threads, quantization choices whose speed impact flips depending on the device, and a Flash Attention regression at long context. I formalized these into a roofline model that predicts measured Ryzen throughput within 4 to 18%, and converted it into concrete, device-aware advice. The model's most interesting prediction — that MoE models should be structurally favored on exactly this kind of hardware — remains the clearest next step. Thank you — I'm happy to take questions.</a:t>
+              <a:t>To close: three consumer and embedded CPUs were enough to recover four concrete, reproducible effects governing CPU-only LLM inference — compute-bound prefill that follows a scalability law, memory-bound generation that can get slower as you add threads, quantization choices whose speed impact flips depending on the device, and a Flash Attention regression at long context. I formalized these into a roofline model that predicts measured Ryzen throughput within 4 to 18%, and converted it into seven concrete, device-aware recommendations. The model's most interesting prediction — that MoE models should be structurally favored on exactly this kind of hardware — remains the clearest next step. Thank you — I'm happy to take questions.</a:t>
             </a:r>
-            <a:endParaRPr b="0" lang="en-GB" sz="2000" spc="-1" strike="noStrike">
-              <a:solidFill>
-                <a:srgbClr val="000000"/>
-              </a:solidFill>
-              <a:latin typeface="Arial"/>
-            </a:endParaRPr>
           </a:p>
         </p:txBody>
       </p:sp>
@@ -4009,27 +3937,9 @@
             <a:noAutofit/>
           </a:bodyPr>
           <a:p>
-            <a:pPr marL="216000" indent="0">
-              <a:lnSpc>
-                <a:spcPct val="100000"/>
-              </a:lnSpc>
-              <a:buNone/>
-            </a:pPr>
             <a:r>
-              <a:rPr b="0" lang="en-US" sz="2000" spc="-1" strike="noStrike">
-                <a:solidFill>
-                  <a:srgbClr val="000000"/>
-                </a:solidFill>
-                <a:latin typeface="Arial"/>
-              </a:rPr>
-              <a:t>Two model families matter here. Dense models — like Qwen or Llama — activate every parameter on every single token. Mixture-of-Experts models replace that with a bank of experts and a router that only activates a handful of them per token — so a 14-billion-parameter model might only touch 2.7 billion parameters to generate one word. On a GPU, where the whole model sits in fast VRAM, that distinction matters less. On a CPU at batch size one — the realistic single-user case — generation is memory-bandwidth-bound, as I'll show you directly. Under that regime, a dense model has to stream its entire weight set from RAM for every token, while an MoE model only streams the experts it actually selected. That's the theoretical hook for this whole thesis. My contributions are: an empirical characterization of four hardware effects across real devices, a roofline-style model that explains them with a handful of calibration constants, an extension of that model to the MoE case, and a public web calculator that implements it.</a:t>
+              <a:t>Two model families matter here. Dense models — like Qwen or Llama — activate every parameter on every single token. Mixture-of-Experts models replace that with a bank of experts and a router that only activates a handful of them per token — so a 14-billion-parameter model might only touch 2.7 billion parameters to generate one word. On a GPU, where the whole model sits in fast VRAM, that distinction matters less. On a CPU at batch size one — the realistic single-user case — generation is memory-bandwidth-bound, as I'll show you directly. Under that regime, a dense model has to stream its entire weight set from RAM for every token, while an MoE model only streams the experts it actually selected. That's the theoretical hook for this whole thesis. My contributions are: an empirical characterization of hardware effects across three real devices, a roofline-style model that explains them with a handful of calibration constants, an extension of that model to the MoE case, and releasing the data, harness, and web calculator publicly on GitHub.</a:t>
             </a:r>
-            <a:endParaRPr b="0" lang="en-GB" sz="2000" spc="-1" strike="noStrike">
-              <a:solidFill>
-                <a:srgbClr val="000000"/>
-              </a:solidFill>
-              <a:latin typeface="Arial"/>
-            </a:endParaRPr>
           </a:p>
         </p:txBody>
       </p:sp>
@@ -4174,27 +4084,9 @@
             <a:noAutofit/>
           </a:bodyPr>
           <a:p>
-            <a:pPr marL="216000" indent="0">
-              <a:lnSpc>
-                <a:spcPct val="100000"/>
-              </a:lnSpc>
-              <a:buNone/>
-            </a:pPr>
             <a:r>
-              <a:rPr b="0" lang="en-US" sz="2000" spc="-1" strike="noStrike">
-                <a:solidFill>
-                  <a:srgbClr val="000000"/>
-                </a:solidFill>
-                <a:latin typeface="Arial"/>
-              </a:rPr>
-              <a:t>I benchmarked four machines, chosen opportunistically from what I had access to, spanning roughly a seventy-times range in raw generation speed. A mid-range AMD Ryzen 5 5600H laptop with dual-channel DDR4 — compute-rich. A low-end Intel Pentium Gold desktop with a single memory channel and just 4 gigabytes of RAM — bandwidth-starved. An NVIDIA Jetson Nano, an embedded ARM board with shared LPDDR4 memory. And a Raspberry Pi 3B, which I'll be upfront about: its benchmark run never completed — the output file has zero usable rows, so it does not appear in any result I'll show you. Everything ran through a resumable harness I built around llama-bench: three to five repetitions per configuration, coefficient of variation under 5% in every case I report, and a row-count-based checkpoint system, because these were multi-hour runs on hardware that wasn't dedicated to benchmarking — a laptop that gets closed, a family desktop that gets used for other things. My first, naive design didn't handle interruption well; it re-ran the same measurements over and over. The second design fixed that, and it's the one behind every number in this talk.</a:t>
+              <a:t>I benchmarked three machines, chosen opportunistically from what I had access to, spanning roughly a seventy-times range in raw generation speed. A mid-range AMD Ryzen 5 5600H laptop with dual-channel DDR4 — compute-rich. A low-end Intel Pentium Gold desktop with a single memory channel and just 4 gigabytes of RAM — bandwidth-starved. And an NVIDIA Jetson Nano, an embedded ARM board with shared LPDDR4 memory. I also attempted a fourth device, a Raspberry Pi 3B, but it's excluded from every result I'll show you: its 1 gigabyte of RAM isn't enough to hold even our most aggressively quantized 7B model alongside the OS and runtime, so it failed with out-of-memory errors before writing a single row of data — a hardware limitation, not a measurement one. Everything else ran through a resumable harness I built around llama-bench: three to five repetitions per configuration, coefficient of variation under 5% in every case I report, and a row-count-based checkpoint system, because these were multi-hour runs on hardware that wasn't dedicated to benchmarking — a laptop that gets closed, a family desktop that gets used for other things. My first, naive design didn't handle interruption well; it re-ran the same measurements over and over. The second design fixed that, and it's the one behind every number in this talk.</a:t>
             </a:r>
-            <a:endParaRPr b="0" lang="en-GB" sz="2000" spc="-1" strike="noStrike">
-              <a:solidFill>
-                <a:srgbClr val="000000"/>
-              </a:solidFill>
-              <a:latin typeface="Arial"/>
-            </a:endParaRPr>
           </a:p>
         </p:txBody>
       </p:sp>
@@ -7479,7 +7371,7 @@
                 <a:latin typeface="Calibri"/>
                 <a:ea typeface="Calibri"/>
               </a:rPr>
-              <a:t>An Empirical Study of llama.cpp Across Four Heterogeneous Devices</a:t>
+              <a:t>An Empirical Study of llama.cpp Across Three Heterogeneous Devices</a:t>
             </a:r>
             <a:endParaRPr b="0" lang="en-GB" sz="1800" spc="-1" strike="noStrike">
               <a:solidFill>
@@ -11671,7 +11563,7 @@
         <p:spPr>
           <a:xfrm>
             <a:off x="548640" y="1600200"/>
-            <a:ext cx="5348880" cy="1416960"/>
+            <a:ext cx="5348880" cy="1300000"/>
           </a:xfrm>
           <a:prstGeom prst="roundRect">
             <a:avLst>
@@ -11930,8 +11822,8 @@
         </p:nvSpPr>
         <p:spPr>
           <a:xfrm>
-            <a:off x="548640" y="3200400"/>
-            <a:ext cx="5348880" cy="1416960"/>
+            <a:off x="548640" y="3050200"/>
+            <a:ext cx="5348880" cy="1300000"/>
           </a:xfrm>
           <a:prstGeom prst="roundRect">
             <a:avLst>
@@ -11976,7 +11868,7 @@
         </p:nvSpPr>
         <p:spPr>
           <a:xfrm>
-            <a:off x="777240" y="3429000"/>
+            <a:off x="777240" y="3278800"/>
             <a:ext cx="456840" cy="456840"/>
           </a:xfrm>
           <a:prstGeom prst="roundRect">
@@ -12019,7 +11911,7 @@
         </p:nvSpPr>
         <p:spPr>
           <a:xfrm>
-            <a:off x="777240" y="3429000"/>
+            <a:off x="777240" y="3278800"/>
             <a:ext cx="456840" cy="456840"/>
           </a:xfrm>
           <a:prstGeom prst="rect">
@@ -12076,7 +11968,7 @@
         </p:nvSpPr>
         <p:spPr>
           <a:xfrm>
-            <a:off x="1417320" y="3364920"/>
+            <a:off x="1417320" y="3214720"/>
             <a:ext cx="4297320" cy="685440"/>
           </a:xfrm>
           <a:prstGeom prst="rect">
@@ -12133,7 +12025,7 @@
         </p:nvSpPr>
         <p:spPr>
           <a:xfrm>
-            <a:off x="1417320" y="4023360"/>
+            <a:off x="1417320" y="3873160"/>
             <a:ext cx="4297320" cy="502560"/>
           </a:xfrm>
           <a:prstGeom prst="rect">
@@ -12190,8 +12082,8 @@
         </p:nvSpPr>
         <p:spPr>
           <a:xfrm>
-            <a:off x="548640" y="4800600"/>
-            <a:ext cx="5348880" cy="1416960"/>
+            <a:off x="548640" y="4500200"/>
+            <a:ext cx="5348880" cy="1300000"/>
           </a:xfrm>
           <a:prstGeom prst="roundRect">
             <a:avLst>
@@ -12236,7 +12128,7 @@
         </p:nvSpPr>
         <p:spPr>
           <a:xfrm>
-            <a:off x="777240" y="5029200"/>
+            <a:off x="777240" y="4728800"/>
             <a:ext cx="456840" cy="456840"/>
           </a:xfrm>
           <a:prstGeom prst="roundRect">
@@ -12279,7 +12171,7 @@
         </p:nvSpPr>
         <p:spPr>
           <a:xfrm>
-            <a:off x="777240" y="5029200"/>
+            <a:off x="777240" y="4728800"/>
             <a:ext cx="456840" cy="456840"/>
           </a:xfrm>
           <a:prstGeom prst="rect">
@@ -12336,7 +12228,7 @@
         </p:nvSpPr>
         <p:spPr>
           <a:xfrm>
-            <a:off x="1417320" y="4965120"/>
+            <a:off x="1417320" y="4664720"/>
             <a:ext cx="4297320" cy="685440"/>
           </a:xfrm>
           <a:prstGeom prst="rect">
@@ -12393,7 +12285,7 @@
         </p:nvSpPr>
         <p:spPr>
           <a:xfrm>
-            <a:off x="1417320" y="5623560"/>
+            <a:off x="1417320" y="5323160"/>
             <a:ext cx="4297320" cy="502560"/>
           </a:xfrm>
           <a:prstGeom prst="rect">
@@ -12451,7 +12343,7 @@
         <p:spPr>
           <a:xfrm>
             <a:off x="6263640" y="1600200"/>
-            <a:ext cx="5348880" cy="1416960"/>
+            <a:ext cx="5348880" cy="1300000"/>
           </a:xfrm>
           <a:prstGeom prst="roundRect">
             <a:avLst>
@@ -12710,8 +12602,8 @@
         </p:nvSpPr>
         <p:spPr>
           <a:xfrm>
-            <a:off x="6263640" y="3200400"/>
-            <a:ext cx="5348880" cy="1416960"/>
+            <a:off x="6263640" y="3050200"/>
+            <a:ext cx="5348880" cy="1300000"/>
           </a:xfrm>
           <a:prstGeom prst="roundRect">
             <a:avLst>
@@ -12756,7 +12648,7 @@
         </p:nvSpPr>
         <p:spPr>
           <a:xfrm>
-            <a:off x="6492240" y="3429000"/>
+            <a:off x="6492240" y="3278800"/>
             <a:ext cx="456840" cy="456840"/>
           </a:xfrm>
           <a:prstGeom prst="roundRect">
@@ -12799,7 +12691,7 @@
         </p:nvSpPr>
         <p:spPr>
           <a:xfrm>
-            <a:off x="6492240" y="3429000"/>
+            <a:off x="6492240" y="3278800"/>
             <a:ext cx="456840" cy="456840"/>
           </a:xfrm>
           <a:prstGeom prst="rect">
@@ -12856,7 +12748,7 @@
         </p:nvSpPr>
         <p:spPr>
           <a:xfrm>
-            <a:off x="7132320" y="3364920"/>
+            <a:off x="7132320" y="3214720"/>
             <a:ext cx="4297320" cy="685440"/>
           </a:xfrm>
           <a:prstGeom prst="rect">
@@ -12913,7 +12805,7 @@
         </p:nvSpPr>
         <p:spPr>
           <a:xfrm>
-            <a:off x="7132320" y="4023360"/>
+            <a:off x="7132320" y="3873160"/>
             <a:ext cx="4297320" cy="502560"/>
           </a:xfrm>
           <a:prstGeom prst="rect">
@@ -12970,8 +12862,8 @@
         </p:nvSpPr>
         <p:spPr>
           <a:xfrm>
-            <a:off x="6263640" y="4800600"/>
-            <a:ext cx="5348880" cy="1416960"/>
+            <a:off x="6263640" y="4500200"/>
+            <a:ext cx="5348880" cy="1300000"/>
           </a:xfrm>
           <a:prstGeom prst="roundRect">
             <a:avLst>
@@ -13016,7 +12908,7 @@
         </p:nvSpPr>
         <p:spPr>
           <a:xfrm>
-            <a:off x="6492240" y="5029200"/>
+            <a:off x="6492240" y="4728800"/>
             <a:ext cx="456840" cy="456840"/>
           </a:xfrm>
           <a:prstGeom prst="roundRect">
@@ -13059,7 +12951,7 @@
         </p:nvSpPr>
         <p:spPr>
           <a:xfrm>
-            <a:off x="6492240" y="5029200"/>
+            <a:off x="6492240" y="4728800"/>
             <a:ext cx="456840" cy="456840"/>
           </a:xfrm>
           <a:prstGeom prst="rect">
@@ -13116,7 +13008,7 @@
         </p:nvSpPr>
         <p:spPr>
           <a:xfrm>
-            <a:off x="7132320" y="4965120"/>
+            <a:off x="7132320" y="4664720"/>
             <a:ext cx="4297320" cy="685440"/>
           </a:xfrm>
           <a:prstGeom prst="rect">
@@ -13173,7 +13065,7 @@
         </p:nvSpPr>
         <p:spPr>
           <a:xfrm>
-            <a:off x="7132320" y="5623560"/>
+            <a:off x="7132320" y="5323160"/>
             <a:ext cx="4297320" cy="502560"/>
           </a:xfrm>
           <a:prstGeom prst="rect">
@@ -13276,6 +13168,143 @@
               </a:solidFill>
               <a:latin typeface="Arial"/>
             </a:endParaRPr>
+          </a:p>
+        </p:txBody>
+      </p:sp>
+      <p:sp>
+        <p:nvSpPr>
+          <p:cNvPr id="259" name="Rounded Rectangle 258"/>
+          <p:cNvSpPr/>
+          <p:nvPr/>
+        </p:nvSpPr>
+        <p:spPr>
+          <a:xfrm>
+            <a:off x="548640" y="5950200"/>
+            <a:ext cx="11063880" cy="340000"/>
+          </a:xfrm>
+          <a:prstGeom prst="roundRect">
+            <a:avLst/>
+          </a:prstGeom>
+          <a:solidFill>
+            <a:srgbClr val="1E2761"/>
+          </a:solidFill>
+          <a:ln>
+            <a:noFill/>
+          </a:ln>
+          <a:effectLst/>
+        </p:spPr>
+        <p:style>
+          <a:lnRef idx="1">
+            <a:schemeClr val="accent1"/>
+          </a:lnRef>
+          <a:fillRef idx="3">
+            <a:schemeClr val="accent1"/>
+          </a:fillRef>
+          <a:effectRef idx="2">
+            <a:schemeClr val="accent1"/>
+          </a:effectRef>
+          <a:fontRef idx="minor">
+            <a:schemeClr val="lt1"/>
+          </a:fontRef>
+        </p:style>
+        <p:txBody>
+          <a:bodyPr rtlCol="0" anchor="ctr"/>
+          <a:lstStyle/>
+          <a:p>
+            <a:pPr algn="ctr"/>
+          </a:p>
+        </p:txBody>
+      </p:sp>
+      <p:sp>
+        <p:nvSpPr>
+          <p:cNvPr id="260" name="Oval 259"/>
+          <p:cNvSpPr/>
+          <p:nvPr/>
+        </p:nvSpPr>
+        <p:spPr>
+          <a:xfrm>
+            <a:off x="777240" y="6005200"/>
+            <a:ext cx="230000" cy="230000"/>
+          </a:xfrm>
+          <a:prstGeom prst="ellipse">
+            <a:avLst/>
+          </a:prstGeom>
+          <a:solidFill>
+            <a:srgbClr val="FFFFFF"/>
+          </a:solidFill>
+          <a:ln>
+            <a:noFill/>
+          </a:ln>
+          <a:effectLst/>
+        </p:spPr>
+        <p:style>
+          <a:lnRef idx="1">
+            <a:schemeClr val="accent1"/>
+          </a:lnRef>
+          <a:fillRef idx="3">
+            <a:schemeClr val="accent1"/>
+          </a:fillRef>
+          <a:effectRef idx="2">
+            <a:schemeClr val="accent1"/>
+          </a:effectRef>
+          <a:fontRef idx="minor">
+            <a:schemeClr val="lt1"/>
+          </a:fontRef>
+        </p:style>
+        <p:txBody>
+          <a:bodyPr rtlCol="0" anchor="ctr" wrap="none"/>
+          <a:lstStyle/>
+          <a:p>
+            <a:pPr algn="ctr"/>
+            <a:r>
+              <a:rPr sz="1400" b="1">
+                <a:solidFill>
+                  <a:srgbClr val="1E2761"/>
+                </a:solidFill>
+              </a:rPr>
+              <a:t>7</a:t>
+            </a:r>
+          </a:p>
+        </p:txBody>
+      </p:sp>
+      <p:sp>
+        <p:nvSpPr>
+          <p:cNvPr id="261" name="TextBox 260"/>
+          <p:cNvSpPr txBox="1"/>
+          <p:nvPr/>
+        </p:nvSpPr>
+        <p:spPr>
+          <a:xfrm>
+            <a:off x="1150000" y="5990200"/>
+            <a:ext cx="10300000" cy="280000"/>
+          </a:xfrm>
+          <a:prstGeom prst="rect">
+            <a:avLst/>
+          </a:prstGeom>
+          <a:noFill/>
+        </p:spPr>
+        <p:txBody>
+          <a:bodyPr wrap="square">
+            <a:spAutoFit/>
+          </a:bodyPr>
+          <a:lstStyle/>
+          <a:p>
+            <a:r>
+              <a:rPr sz="1300" b="1">
+                <a:solidFill>
+                  <a:srgbClr val="FFFFFF"/>
+                </a:solidFill>
+              </a:rPr>
+              <a:t>Match model size to the device's memory budget — </a:t>
+            </a:r>
+            <a:r>
+              <a:rPr sz="1300">
+                <a:solidFill>
+                  <a:srgbClr val="CADCFC"/>
+                </a:solidFill>
+              </a:rPr>
+              <a:t>a model that doesn't fit in RAM will thrash or fail outright.</a:t>
+            </a:r>
           </a:p>
         </p:txBody>
       </p:sp>
@@ -14318,6 +14347,78 @@
           </a:p>
         </p:txBody>
       </p:sp>
+      <p:pic>
+        <p:nvPicPr>
+          <p:cNvPr id="278" name="Picture 277" descr="icon_scale.png"/>
+          <p:cNvPicPr>
+            <a:picLocks noChangeAspect="1"/>
+          </p:cNvPicPr>
+          <p:nvPr/>
+        </p:nvPicPr>
+        <p:blipFill>
+          <a:blip r:embed="rId3"/>
+          <a:stretch>
+            <a:fillRect/>
+          </a:stretch>
+        </p:blipFill>
+        <p:spPr>
+          <a:xfrm>
+            <a:off x="905660" y="2440120"/>
+            <a:ext cx="200000" cy="200000"/>
+          </a:xfrm>
+          <a:prstGeom prst="rect">
+            <a:avLst/>
+          </a:prstGeom>
+        </p:spPr>
+      </p:pic>
+      <p:pic>
+        <p:nvPicPr>
+          <p:cNvPr id="279" name="Picture 278" descr="icon_flask.png"/>
+          <p:cNvPicPr>
+            <a:picLocks noChangeAspect="1"/>
+          </p:cNvPicPr>
+          <p:nvPr/>
+        </p:nvPicPr>
+        <p:blipFill>
+          <a:blip r:embed="rId4"/>
+          <a:stretch>
+            <a:fillRect/>
+          </a:stretch>
+        </p:blipFill>
+        <p:spPr>
+          <a:xfrm>
+            <a:off x="905660" y="3857440"/>
+            <a:ext cx="200000" cy="200000"/>
+          </a:xfrm>
+          <a:prstGeom prst="rect">
+            <a:avLst/>
+          </a:prstGeom>
+        </p:spPr>
+      </p:pic>
+      <p:pic>
+        <p:nvPicPr>
+          <p:cNvPr id="280" name="Picture 279" descr="icon_chart.png"/>
+          <p:cNvPicPr>
+            <a:picLocks noChangeAspect="1"/>
+          </p:cNvPicPr>
+          <p:nvPr/>
+        </p:nvPicPr>
+        <p:blipFill>
+          <a:blip r:embed="rId5"/>
+          <a:stretch>
+            <a:fillRect/>
+          </a:stretch>
+        </p:blipFill>
+        <p:spPr>
+          <a:xfrm>
+            <a:off x="905660" y="5274760"/>
+            <a:ext cx="200000" cy="200000"/>
+          </a:xfrm>
+          <a:prstGeom prst="rect">
+            <a:avLst/>
+          </a:prstGeom>
+        </p:spPr>
+      </p:pic>
     </p:spTree>
   </p:cSld>
   <mc:AlternateContent>
@@ -14659,7 +14760,7 @@
                 <a:latin typeface="Calibri"/>
                 <a:ea typeface="Calibri"/>
               </a:rPr>
-              <a:t>Expand the fleet: a working Raspberry Pi, an AVX-512 chip, Apple Silicon</a:t>
+              <a:t>Expand the fleet: a Raspberry Pi 4 or 5, an AVX-512 chip, Apple Silicon</a:t>
             </a:r>
             <a:endParaRPr b="0" lang="en-GB" sz="1250" spc="-1" strike="noStrike">
               <a:solidFill>
@@ -15751,7 +15852,7 @@
                 <a:latin typeface="Cambria"/>
                 <a:ea typeface="Cambria"/>
               </a:rPr>
-              <a:t>Four effects, one model, six recommendations</a:t>
+              <a:t>Four effects, one model, seven recommendations</a:t>
             </a:r>
             <a:endParaRPr b="0" lang="en-GB" sz="3000" spc="-1" strike="noStrike">
               <a:solidFill>
@@ -16576,47 +16677,6 @@
       </p:sp>
       <p:sp>
         <p:nvSpPr>
-          <p:cNvPr id="59" name="Shape 3"/>
-          <p:cNvSpPr/>
-          <p:nvPr/>
-        </p:nvSpPr>
-        <p:spPr>
-          <a:xfrm>
-            <a:off x="548640" y="2468880"/>
-            <a:ext cx="145800" cy="145800"/>
-          </a:xfrm>
-          <a:prstGeom prst="ellipse">
-            <a:avLst/>
-          </a:prstGeom>
-          <a:solidFill>
-            <a:srgbClr val="1f8a9e"/>
-          </a:solidFill>
-          <a:ln w="0">
-            <a:noFill/>
-          </a:ln>
-        </p:spPr>
-        <p:style>
-          <a:lnRef idx="0"/>
-          <a:fillRef idx="0"/>
-          <a:effectRef idx="0"/>
-          <a:fontRef idx="minor"/>
-        </p:style>
-        <p:txBody>
-          <a:bodyPr lIns="90000" rIns="90000" tIns="45000" bIns="45000" anchor="t">
-            <a:noAutofit/>
-          </a:bodyPr>
-          <a:p>
-            <a:endParaRPr b="0" lang="en-GB" sz="1800" spc="-1" strike="noStrike">
-              <a:solidFill>
-                <a:srgbClr val="000000"/>
-              </a:solidFill>
-              <a:latin typeface="Arial"/>
-            </a:endParaRPr>
-          </a:p>
-        </p:txBody>
-      </p:sp>
-      <p:sp>
-        <p:nvSpPr>
           <p:cNvPr id="60" name="Text 4"/>
           <p:cNvSpPr/>
           <p:nvPr/>
@@ -16731,47 +16791,6 @@
       </p:sp>
       <p:sp>
         <p:nvSpPr>
-          <p:cNvPr id="62" name="Shape 6"/>
-          <p:cNvSpPr/>
-          <p:nvPr/>
-        </p:nvSpPr>
-        <p:spPr>
-          <a:xfrm>
-            <a:off x="548640" y="3182040"/>
-            <a:ext cx="145800" cy="145800"/>
-          </a:xfrm>
-          <a:prstGeom prst="ellipse">
-            <a:avLst/>
-          </a:prstGeom>
-          <a:solidFill>
-            <a:srgbClr val="1f8a9e"/>
-          </a:solidFill>
-          <a:ln w="0">
-            <a:noFill/>
-          </a:ln>
-        </p:spPr>
-        <p:style>
-          <a:lnRef idx="0"/>
-          <a:fillRef idx="0"/>
-          <a:effectRef idx="0"/>
-          <a:fontRef idx="minor"/>
-        </p:style>
-        <p:txBody>
-          <a:bodyPr lIns="90000" rIns="90000" tIns="45000" bIns="45000" anchor="t">
-            <a:noAutofit/>
-          </a:bodyPr>
-          <a:p>
-            <a:endParaRPr b="0" lang="en-GB" sz="1800" spc="-1" strike="noStrike">
-              <a:solidFill>
-                <a:srgbClr val="000000"/>
-              </a:solidFill>
-              <a:latin typeface="Arial"/>
-            </a:endParaRPr>
-          </a:p>
-        </p:txBody>
-      </p:sp>
-      <p:sp>
-        <p:nvSpPr>
           <p:cNvPr id="63" name="Text 7"/>
           <p:cNvSpPr/>
           <p:nvPr/>
@@ -16886,47 +16905,6 @@
       </p:sp>
       <p:sp>
         <p:nvSpPr>
-          <p:cNvPr id="65" name="Shape 9"/>
-          <p:cNvSpPr/>
-          <p:nvPr/>
-        </p:nvSpPr>
-        <p:spPr>
-          <a:xfrm>
-            <a:off x="548640" y="3895200"/>
-            <a:ext cx="145800" cy="145800"/>
-          </a:xfrm>
-          <a:prstGeom prst="ellipse">
-            <a:avLst/>
-          </a:prstGeom>
-          <a:solidFill>
-            <a:srgbClr val="1f8a9e"/>
-          </a:solidFill>
-          <a:ln w="0">
-            <a:noFill/>
-          </a:ln>
-        </p:spPr>
-        <p:style>
-          <a:lnRef idx="0"/>
-          <a:fillRef idx="0"/>
-          <a:effectRef idx="0"/>
-          <a:fontRef idx="minor"/>
-        </p:style>
-        <p:txBody>
-          <a:bodyPr lIns="90000" rIns="90000" tIns="45000" bIns="45000" anchor="t">
-            <a:noAutofit/>
-          </a:bodyPr>
-          <a:p>
-            <a:endParaRPr b="0" lang="en-GB" sz="1800" spc="-1" strike="noStrike">
-              <a:solidFill>
-                <a:srgbClr val="000000"/>
-              </a:solidFill>
-              <a:latin typeface="Arial"/>
-            </a:endParaRPr>
-          </a:p>
-        </p:txBody>
-      </p:sp>
-      <p:sp>
-        <p:nvSpPr>
           <p:cNvPr id="66" name="Text 10"/>
           <p:cNvSpPr/>
           <p:nvPr/>
@@ -17041,47 +17019,6 @@
       </p:sp>
       <p:sp>
         <p:nvSpPr>
-          <p:cNvPr id="68" name="Shape 12"/>
-          <p:cNvSpPr/>
-          <p:nvPr/>
-        </p:nvSpPr>
-        <p:spPr>
-          <a:xfrm>
-            <a:off x="548640" y="4608720"/>
-            <a:ext cx="145800" cy="145800"/>
-          </a:xfrm>
-          <a:prstGeom prst="ellipse">
-            <a:avLst/>
-          </a:prstGeom>
-          <a:solidFill>
-            <a:srgbClr val="1f8a9e"/>
-          </a:solidFill>
-          <a:ln w="0">
-            <a:noFill/>
-          </a:ln>
-        </p:spPr>
-        <p:style>
-          <a:lnRef idx="0"/>
-          <a:fillRef idx="0"/>
-          <a:effectRef idx="0"/>
-          <a:fontRef idx="minor"/>
-        </p:style>
-        <p:txBody>
-          <a:bodyPr lIns="90000" rIns="90000" tIns="45000" bIns="45000" anchor="t">
-            <a:noAutofit/>
-          </a:bodyPr>
-          <a:p>
-            <a:endParaRPr b="0" lang="en-GB" sz="1800" spc="-1" strike="noStrike">
-              <a:solidFill>
-                <a:srgbClr val="000000"/>
-              </a:solidFill>
-              <a:latin typeface="Arial"/>
-            </a:endParaRPr>
-          </a:p>
-        </p:txBody>
-      </p:sp>
-      <p:sp>
-        <p:nvSpPr>
           <p:cNvPr id="69" name="Text 13"/>
           <p:cNvSpPr/>
           <p:nvPr/>
@@ -17513,6 +17450,278 @@
           </a:p>
         </p:txBody>
       </p:sp>
+      <p:sp>
+        <p:nvSpPr>
+          <p:cNvPr id="77" name="Oval 76"/>
+          <p:cNvSpPr/>
+          <p:nvPr/>
+        </p:nvSpPr>
+        <p:spPr>
+          <a:xfrm>
+            <a:off x="508640" y="2378880"/>
+            <a:ext cx="320000" cy="320000"/>
+          </a:xfrm>
+          <a:prstGeom prst="ellipse">
+            <a:avLst/>
+          </a:prstGeom>
+          <a:solidFill>
+            <a:srgbClr val="1E2761"/>
+          </a:solidFill>
+          <a:ln>
+            <a:noFill/>
+          </a:ln>
+          <a:effectLst/>
+        </p:spPr>
+        <p:style>
+          <a:lnRef idx="1">
+            <a:schemeClr val="accent1"/>
+          </a:lnRef>
+          <a:fillRef idx="3">
+            <a:schemeClr val="accent1"/>
+          </a:fillRef>
+          <a:effectRef idx="2">
+            <a:schemeClr val="accent1"/>
+          </a:effectRef>
+          <a:fontRef idx="minor">
+            <a:schemeClr val="lt1"/>
+          </a:fontRef>
+        </p:style>
+        <p:txBody>
+          <a:bodyPr rtlCol="0" anchor="ctr"/>
+          <a:lstStyle/>
+          <a:p>
+            <a:pPr algn="ctr"/>
+          </a:p>
+        </p:txBody>
+      </p:sp>
+      <p:pic>
+        <p:nvPicPr>
+          <p:cNvPr id="78" name="Picture 77" descr="icon_laptop.png"/>
+          <p:cNvPicPr>
+            <a:picLocks noChangeAspect="1"/>
+          </p:cNvPicPr>
+          <p:nvPr/>
+        </p:nvPicPr>
+        <p:blipFill>
+          <a:blip r:embed="rId3"/>
+          <a:stretch>
+            <a:fillRect/>
+          </a:stretch>
+        </p:blipFill>
+        <p:spPr>
+          <a:xfrm>
+            <a:off x="578640" y="2448880"/>
+            <a:ext cx="180000" cy="180000"/>
+          </a:xfrm>
+          <a:prstGeom prst="rect">
+            <a:avLst/>
+          </a:prstGeom>
+        </p:spPr>
+      </p:pic>
+      <p:sp>
+        <p:nvSpPr>
+          <p:cNvPr id="79" name="Oval 78"/>
+          <p:cNvSpPr/>
+          <p:nvPr/>
+        </p:nvSpPr>
+        <p:spPr>
+          <a:xfrm>
+            <a:off x="508640" y="3092040"/>
+            <a:ext cx="320000" cy="320000"/>
+          </a:xfrm>
+          <a:prstGeom prst="ellipse">
+            <a:avLst/>
+          </a:prstGeom>
+          <a:solidFill>
+            <a:srgbClr val="1E2761"/>
+          </a:solidFill>
+          <a:ln>
+            <a:noFill/>
+          </a:ln>
+          <a:effectLst/>
+        </p:spPr>
+        <p:style>
+          <a:lnRef idx="1">
+            <a:schemeClr val="accent1"/>
+          </a:lnRef>
+          <a:fillRef idx="3">
+            <a:schemeClr val="accent1"/>
+          </a:fillRef>
+          <a:effectRef idx="2">
+            <a:schemeClr val="accent1"/>
+          </a:effectRef>
+          <a:fontRef idx="minor">
+            <a:schemeClr val="lt1"/>
+          </a:fontRef>
+        </p:style>
+        <p:txBody>
+          <a:bodyPr rtlCol="0" anchor="ctr"/>
+          <a:lstStyle/>
+          <a:p>
+            <a:pPr algn="ctr"/>
+          </a:p>
+        </p:txBody>
+      </p:sp>
+      <p:pic>
+        <p:nvPicPr>
+          <p:cNvPr id="80" name="Picture 79" descr="icon_desktop.png"/>
+          <p:cNvPicPr>
+            <a:picLocks noChangeAspect="1"/>
+          </p:cNvPicPr>
+          <p:nvPr/>
+        </p:nvPicPr>
+        <p:blipFill>
+          <a:blip r:embed="rId4"/>
+          <a:stretch>
+            <a:fillRect/>
+          </a:stretch>
+        </p:blipFill>
+        <p:spPr>
+          <a:xfrm>
+            <a:off x="578640" y="3162040"/>
+            <a:ext cx="180000" cy="180000"/>
+          </a:xfrm>
+          <a:prstGeom prst="rect">
+            <a:avLst/>
+          </a:prstGeom>
+        </p:spPr>
+      </p:pic>
+      <p:sp>
+        <p:nvSpPr>
+          <p:cNvPr id="81" name="Oval 80"/>
+          <p:cNvSpPr/>
+          <p:nvPr/>
+        </p:nvSpPr>
+        <p:spPr>
+          <a:xfrm>
+            <a:off x="508640" y="3805200"/>
+            <a:ext cx="320000" cy="320000"/>
+          </a:xfrm>
+          <a:prstGeom prst="ellipse">
+            <a:avLst/>
+          </a:prstGeom>
+          <a:solidFill>
+            <a:srgbClr val="1E2761"/>
+          </a:solidFill>
+          <a:ln>
+            <a:noFill/>
+          </a:ln>
+          <a:effectLst/>
+        </p:spPr>
+        <p:style>
+          <a:lnRef idx="1">
+            <a:schemeClr val="accent1"/>
+          </a:lnRef>
+          <a:fillRef idx="3">
+            <a:schemeClr val="accent1"/>
+          </a:fillRef>
+          <a:effectRef idx="2">
+            <a:schemeClr val="accent1"/>
+          </a:effectRef>
+          <a:fontRef idx="minor">
+            <a:schemeClr val="lt1"/>
+          </a:fontRef>
+        </p:style>
+        <p:txBody>
+          <a:bodyPr rtlCol="0" anchor="ctr"/>
+          <a:lstStyle/>
+          <a:p>
+            <a:pPr algn="ctr"/>
+          </a:p>
+        </p:txBody>
+      </p:sp>
+      <p:pic>
+        <p:nvPicPr>
+          <p:cNvPr id="82" name="Picture 81" descr="icon_rpi.png"/>
+          <p:cNvPicPr>
+            <a:picLocks noChangeAspect="1"/>
+          </p:cNvPicPr>
+          <p:nvPr/>
+        </p:nvPicPr>
+        <p:blipFill>
+          <a:blip r:embed="rId5"/>
+          <a:stretch>
+            <a:fillRect/>
+          </a:stretch>
+        </p:blipFill>
+        <p:spPr>
+          <a:xfrm>
+            <a:off x="578640" y="3875200"/>
+            <a:ext cx="180000" cy="180000"/>
+          </a:xfrm>
+          <a:prstGeom prst="rect">
+            <a:avLst/>
+          </a:prstGeom>
+        </p:spPr>
+      </p:pic>
+      <p:sp>
+        <p:nvSpPr>
+          <p:cNvPr id="83" name="Oval 82"/>
+          <p:cNvSpPr/>
+          <p:nvPr/>
+        </p:nvSpPr>
+        <p:spPr>
+          <a:xfrm>
+            <a:off x="508640" y="4518720"/>
+            <a:ext cx="320000" cy="320000"/>
+          </a:xfrm>
+          <a:prstGeom prst="ellipse">
+            <a:avLst/>
+          </a:prstGeom>
+          <a:solidFill>
+            <a:srgbClr val="1E2761"/>
+          </a:solidFill>
+          <a:ln>
+            <a:noFill/>
+          </a:ln>
+          <a:effectLst/>
+        </p:spPr>
+        <p:style>
+          <a:lnRef idx="1">
+            <a:schemeClr val="accent1"/>
+          </a:lnRef>
+          <a:fillRef idx="3">
+            <a:schemeClr val="accent1"/>
+          </a:fillRef>
+          <a:effectRef idx="2">
+            <a:schemeClr val="accent1"/>
+          </a:effectRef>
+          <a:fontRef idx="minor">
+            <a:schemeClr val="lt1"/>
+          </a:fontRef>
+        </p:style>
+        <p:txBody>
+          <a:bodyPr rtlCol="0" anchor="ctr"/>
+          <a:lstStyle/>
+          <a:p>
+            <a:pPr algn="ctr"/>
+          </a:p>
+        </p:txBody>
+      </p:sp>
+      <p:pic>
+        <p:nvPicPr>
+          <p:cNvPr id="84" name="Picture 83" descr="icon_chip.png"/>
+          <p:cNvPicPr>
+            <a:picLocks noChangeAspect="1"/>
+          </p:cNvPicPr>
+          <p:nvPr/>
+        </p:nvPicPr>
+        <p:blipFill>
+          <a:blip r:embed="rId6"/>
+          <a:stretch>
+            <a:fillRect/>
+          </a:stretch>
+        </p:blipFill>
+        <p:spPr>
+          <a:xfrm>
+            <a:off x="578640" y="4588720"/>
+            <a:ext cx="180000" cy="180000"/>
+          </a:xfrm>
+          <a:prstGeom prst="rect">
+            <a:avLst/>
+          </a:prstGeom>
+        </p:spPr>
+      </p:pic>
     </p:spTree>
   </p:cSld>
   <mc:AlternateContent>
@@ -18450,6 +18659,78 @@
           </a:p>
         </p:txBody>
       </p:sp>
+      <p:pic>
+        <p:nvPicPr>
+          <p:cNvPr id="93" name="Picture 92" descr="image.png"/>
+          <p:cNvPicPr>
+            <a:picLocks noChangeAspect="1"/>
+          </p:cNvPicPr>
+          <p:nvPr/>
+        </p:nvPicPr>
+        <p:blipFill>
+          <a:blip r:embed="rId3"/>
+          <a:stretch>
+            <a:fillRect/>
+          </a:stretch>
+        </p:blipFill>
+        <p:spPr>
+          <a:xfrm>
+            <a:off x="3588720" y="2498880"/>
+            <a:ext cx="240000" cy="240000"/>
+          </a:xfrm>
+          <a:prstGeom prst="rect">
+            <a:avLst/>
+          </a:prstGeom>
+        </p:spPr>
+      </p:pic>
+      <p:pic>
+        <p:nvPicPr>
+          <p:cNvPr id="94" name="Picture 93" descr="image.png"/>
+          <p:cNvPicPr>
+            <a:picLocks noChangeAspect="1"/>
+          </p:cNvPicPr>
+          <p:nvPr/>
+        </p:nvPicPr>
+        <p:blipFill>
+          <a:blip r:embed="rId4"/>
+          <a:stretch>
+            <a:fillRect/>
+          </a:stretch>
+        </p:blipFill>
+        <p:spPr>
+          <a:xfrm>
+            <a:off x="7383480" y="2498880"/>
+            <a:ext cx="240000" cy="240000"/>
+          </a:xfrm>
+          <a:prstGeom prst="rect">
+            <a:avLst/>
+          </a:prstGeom>
+        </p:spPr>
+      </p:pic>
+      <p:pic>
+        <p:nvPicPr>
+          <p:cNvPr id="95" name="Picture 94" descr="image.png"/>
+          <p:cNvPicPr>
+            <a:picLocks noChangeAspect="1"/>
+          </p:cNvPicPr>
+          <p:nvPr/>
+        </p:nvPicPr>
+        <p:blipFill>
+          <a:blip r:embed="rId5"/>
+          <a:stretch>
+            <a:fillRect/>
+          </a:stretch>
+        </p:blipFill>
+        <p:spPr>
+          <a:xfrm>
+            <a:off x="11178240" y="2498880"/>
+            <a:ext cx="240000" cy="240000"/>
+          </a:xfrm>
+          <a:prstGeom prst="rect">
+            <a:avLst/>
+          </a:prstGeom>
+        </p:spPr>
+      </p:pic>
     </p:spTree>
   </p:cSld>
   <mc:AlternateContent>
@@ -19592,7 +19873,7 @@
                 <a:latin typeface="Calibri"/>
                 <a:ea typeface="Calibri"/>
               </a:rPr>
-              <a:t>A public, interactive web calculator implementing the model for practitioners</a:t>
+              <a:t>Open data, benchmarking harness, and web calculator, released publicly on GitHub</a:t>
             </a:r>
             <a:endParaRPr b="0" lang="en-GB" sz="1300" spc="-1" strike="noStrike">
               <a:solidFill>
@@ -19800,7 +20081,7 @@
                 <a:latin typeface="Cambria"/>
                 <a:ea typeface="Cambria"/>
               </a:rPr>
-              <a:t>Four machines, a ~70× throughput range</a:t>
+              <a:t>Three machines, a ~70× throughput range</a:t>
             </a:r>
             <a:endParaRPr b="0" lang="en-GB" sz="3000" spc="-1" strike="noStrike">
               <a:solidFill>
@@ -19819,7 +20100,7 @@
         </p:nvGraphicFramePr>
         <p:xfrm>
           <a:off x="548640" y="1600200"/>
-          <a:ext cx="11063880" cy="2286000"/>
+          <a:ext cx="11063880" cy="1828800"/>
         </p:xfrm>
         <a:graphic>
           <a:graphicData uri="http://schemas.openxmlformats.org/drawingml/2006/table">
@@ -20807,248 +21088,6 @@
                   </a:tcPr>
                 </a:tc>
               </a:tr>
-              <a:tr h="457200">
-                <a:tc>
-                  <a:txBody>
-                    <a:bodyPr anchor="ctr">
-                      <a:noAutofit/>
-                    </a:bodyPr>
-                    <a:p>
-                      <a:pPr defTabSz="914400">
-                        <a:lnSpc>
-                          <a:spcPct val="100000"/>
-                        </a:lnSpc>
-                        <a:tabLst>
-                          <a:tab algn="l" pos="0"/>
-                        </a:tabLst>
-                      </a:pPr>
-                      <a:r>
-                        <a:rPr b="0" lang="en-US" sz="1200" spc="-1" strike="noStrike">
-                          <a:solidFill>
-                            <a:srgbClr val="1b2430"/>
-                          </a:solidFill>
-                          <a:latin typeface="Calibri"/>
-                          <a:ea typeface="Calibri"/>
-                        </a:rPr>
-                        <a:t>Raspberry Pi 3B</a:t>
-                      </a:r>
-                      <a:endParaRPr b="0" lang="en-GB" sz="1200" spc="-1" strike="noStrike">
-                        <a:solidFill>
-                          <a:srgbClr val="000000"/>
-                        </a:solidFill>
-                        <a:latin typeface="Arial"/>
-                      </a:endParaRPr>
-                    </a:p>
-                  </a:txBody>
-                  <a:tcPr anchor="ctr" marL="91440" marR="91440">
-                    <a:lnL w="12240">
-                      <a:solidFill>
-                        <a:srgbClr val="e3e8ec"/>
-                      </a:solidFill>
-                      <a:prstDash val="solid"/>
-                    </a:lnL>
-                    <a:lnR w="12240">
-                      <a:solidFill>
-                        <a:srgbClr val="e3e8ec"/>
-                      </a:solidFill>
-                      <a:prstDash val="solid"/>
-                    </a:lnR>
-                    <a:lnT w="12240">
-                      <a:solidFill>
-                        <a:srgbClr val="e3e8ec"/>
-                      </a:solidFill>
-                      <a:prstDash val="solid"/>
-                    </a:lnT>
-                    <a:lnB w="12240">
-                      <a:solidFill>
-                        <a:srgbClr val="e3e8ec"/>
-                      </a:solidFill>
-                      <a:prstDash val="solid"/>
-                    </a:lnB>
-                    <a:noFill/>
-                  </a:tcPr>
-                </a:tc>
-                <a:tc>
-                  <a:txBody>
-                    <a:bodyPr anchor="ctr">
-                      <a:noAutofit/>
-                    </a:bodyPr>
-                    <a:p>
-                      <a:pPr defTabSz="914400">
-                        <a:lnSpc>
-                          <a:spcPct val="100000"/>
-                        </a:lnSpc>
-                        <a:tabLst>
-                          <a:tab algn="l" pos="0"/>
-                        </a:tabLst>
-                      </a:pPr>
-                      <a:r>
-                        <a:rPr b="0" lang="en-US" sz="1200" spc="-1" strike="noStrike">
-                          <a:solidFill>
-                            <a:srgbClr val="1b2430"/>
-                          </a:solidFill>
-                          <a:latin typeface="Calibri"/>
-                          <a:ea typeface="Calibri"/>
-                        </a:rPr>
-                        <a:t>ARM Cortex-A53 (4C/4T)</a:t>
-                      </a:r>
-                      <a:endParaRPr b="0" lang="en-GB" sz="1200" spc="-1" strike="noStrike">
-                        <a:solidFill>
-                          <a:srgbClr val="000000"/>
-                        </a:solidFill>
-                        <a:latin typeface="Arial"/>
-                      </a:endParaRPr>
-                    </a:p>
-                  </a:txBody>
-                  <a:tcPr anchor="ctr" marL="91440" marR="91440">
-                    <a:lnL w="12240">
-                      <a:solidFill>
-                        <a:srgbClr val="e3e8ec"/>
-                      </a:solidFill>
-                      <a:prstDash val="solid"/>
-                    </a:lnL>
-                    <a:lnR w="12240">
-                      <a:solidFill>
-                        <a:srgbClr val="e3e8ec"/>
-                      </a:solidFill>
-                      <a:prstDash val="solid"/>
-                    </a:lnR>
-                    <a:lnT w="12240">
-                      <a:solidFill>
-                        <a:srgbClr val="e3e8ec"/>
-                      </a:solidFill>
-                      <a:prstDash val="solid"/>
-                    </a:lnT>
-                    <a:lnB w="12240">
-                      <a:solidFill>
-                        <a:srgbClr val="e3e8ec"/>
-                      </a:solidFill>
-                      <a:prstDash val="solid"/>
-                    </a:lnB>
-                    <a:noFill/>
-                  </a:tcPr>
-                </a:tc>
-                <a:tc>
-                  <a:txBody>
-                    <a:bodyPr anchor="ctr">
-                      <a:noAutofit/>
-                    </a:bodyPr>
-                    <a:p>
-                      <a:pPr defTabSz="914400">
-                        <a:lnSpc>
-                          <a:spcPct val="100000"/>
-                        </a:lnSpc>
-                        <a:tabLst>
-                          <a:tab algn="l" pos="0"/>
-                        </a:tabLst>
-                      </a:pPr>
-                      <a:r>
-                        <a:rPr b="0" lang="en-US" sz="1200" spc="-1" strike="noStrike">
-                          <a:solidFill>
-                            <a:srgbClr val="1b2430"/>
-                          </a:solidFill>
-                          <a:latin typeface="Calibri"/>
-                          <a:ea typeface="Calibri"/>
-                        </a:rPr>
-                        <a:t>0.9GB LPDDR2, ~3.2 GB/s</a:t>
-                      </a:r>
-                      <a:endParaRPr b="0" lang="en-GB" sz="1200" spc="-1" strike="noStrike">
-                        <a:solidFill>
-                          <a:srgbClr val="000000"/>
-                        </a:solidFill>
-                        <a:latin typeface="Arial"/>
-                      </a:endParaRPr>
-                    </a:p>
-                  </a:txBody>
-                  <a:tcPr anchor="ctr" marL="91440" marR="91440">
-                    <a:lnL w="12240">
-                      <a:solidFill>
-                        <a:srgbClr val="e3e8ec"/>
-                      </a:solidFill>
-                      <a:prstDash val="solid"/>
-                    </a:lnL>
-                    <a:lnR w="12240">
-                      <a:solidFill>
-                        <a:srgbClr val="e3e8ec"/>
-                      </a:solidFill>
-                      <a:prstDash val="solid"/>
-                    </a:lnR>
-                    <a:lnT w="12240">
-                      <a:solidFill>
-                        <a:srgbClr val="e3e8ec"/>
-                      </a:solidFill>
-                      <a:prstDash val="solid"/>
-                    </a:lnT>
-                    <a:lnB w="12240">
-                      <a:solidFill>
-                        <a:srgbClr val="e3e8ec"/>
-                      </a:solidFill>
-                      <a:prstDash val="solid"/>
-                    </a:lnB>
-                    <a:noFill/>
-                  </a:tcPr>
-                </a:tc>
-                <a:tc>
-                  <a:txBody>
-                    <a:bodyPr anchor="ctr">
-                      <a:noAutofit/>
-                    </a:bodyPr>
-                    <a:p>
-                      <a:pPr defTabSz="914400">
-                        <a:lnSpc>
-                          <a:spcPct val="100000"/>
-                        </a:lnSpc>
-                        <a:tabLst>
-                          <a:tab algn="l" pos="0"/>
-                        </a:tabLst>
-                      </a:pPr>
-                      <a:r>
-                        <a:rPr b="0" i="1" lang="en-US" sz="1200" spc="-1" strike="noStrike">
-                          <a:solidFill>
-                            <a:srgbClr val="5b6675"/>
-                          </a:solidFill>
-                          <a:latin typeface="Calibri"/>
-                          <a:ea typeface="Calibri"/>
-                        </a:rPr>
-                        <a:t>Attempted — no usable data</a:t>
-                      </a:r>
-                      <a:endParaRPr b="0" lang="en-GB" sz="1200" spc="-1" strike="noStrike">
-                        <a:solidFill>
-                          <a:srgbClr val="000000"/>
-                        </a:solidFill>
-                        <a:latin typeface="Arial"/>
-                      </a:endParaRPr>
-                    </a:p>
-                  </a:txBody>
-                  <a:tcPr anchor="ctr" marL="91440" marR="91440">
-                    <a:lnL w="12240">
-                      <a:solidFill>
-                        <a:srgbClr val="e3e8ec"/>
-                      </a:solidFill>
-                      <a:prstDash val="solid"/>
-                    </a:lnL>
-                    <a:lnR w="12240">
-                      <a:solidFill>
-                        <a:srgbClr val="e3e8ec"/>
-                      </a:solidFill>
-                      <a:prstDash val="solid"/>
-                    </a:lnR>
-                    <a:lnT w="12240">
-                      <a:solidFill>
-                        <a:srgbClr val="e3e8ec"/>
-                      </a:solidFill>
-                      <a:prstDash val="solid"/>
-                    </a:lnT>
-                    <a:lnB w="12240">
-                      <a:solidFill>
-                        <a:srgbClr val="e3e8ec"/>
-                      </a:solidFill>
-                      <a:prstDash val="solid"/>
-                    </a:lnB>
-                    <a:noFill/>
-                  </a:tcPr>
-                </a:tc>
-              </a:tr>
             </a:tbl>
           </a:graphicData>
         </a:graphic>
@@ -21427,6 +21466,39 @@
               </a:solidFill>
               <a:latin typeface="Arial"/>
             </a:endParaRPr>
+          </a:p>
+        </p:txBody>
+      </p:sp>
+      <p:sp>
+        <p:nvSpPr>
+          <p:cNvPr id="125" name="TextBox 124"/>
+          <p:cNvSpPr txBox="1"/>
+          <p:nvPr/>
+        </p:nvSpPr>
+        <p:spPr>
+          <a:xfrm>
+            <a:off x="548640" y="3520000"/>
+            <a:ext cx="11063880" cy="560000"/>
+          </a:xfrm>
+          <a:prstGeom prst="rect">
+            <a:avLst/>
+          </a:prstGeom>
+          <a:noFill/>
+        </p:spPr>
+        <p:txBody>
+          <a:bodyPr wrap="square">
+            <a:spAutoFit/>
+          </a:bodyPr>
+          <a:lstStyle/>
+          <a:p>
+            <a:r>
+              <a:rPr sz="1200" i="1">
+                <a:solidFill>
+                  <a:srgbClr val="6B7280"/>
+                </a:solidFill>
+              </a:rPr>
+              <a:t>A fourth device, a Raspberry Pi 3B, was also attempted but is excluded from the fleet above: its 1GB of RAM cannot hold even our most aggressively quantized 7B model, so every run failed with an out-of-memory error before a single benchmark row was written.</a:t>
+            </a:r>
           </a:p>
         </p:txBody>
       </p:sp>

</xml_diff>